<commit_message>
Add safe provider preview and honest showcase
</commit_message>
<xml_diff>
--- a/examples/pptrans-demo.en.pptx
+++ b/examples/pptrans-demo.en.pptx
@@ -1372,7 +1372,7 @@
       </p:sp>
       <p:sp>
         <p:nvSpPr>
-          <p:cNvPr id="4" name="repository-link">
+          <p:cNvPr id="4" name="showcase-status">
             <a:extLst xmlns:a="http://schemas.openxmlformats.org/drawingml/2006/main">
               <a:ext uri="{FF2B5EF4-FFF2-40B4-BE49-F238E27FC236}">
                 <a16:creationId xmlns:a16="http://schemas.microsoft.com/office/drawing/2014/main" id="{0B0BB416-669A-447C-9616-292E38D5B80C}"/>
@@ -1422,9 +1422,8 @@
                 <a:latin typeface="Arial"/>
                 <a:ea typeface="Arial"/>
                 <a:cs typeface="Arial"/>
-                <a:hlinkClick xmlns:r="http://schemas.openxmlformats.org/officeDocument/2006/relationships" r:id="Rc75ac80989fe41ad"/>
               </a:rPr>
-              <a:t>github.com/Z-MarkUs/PPTrans</a:t>
+              <a:t>PPTrans v2 • unreleased local showcase</a:t>
             </a:r>
           </a:p>
         </p:txBody>

</xml_diff>